<commit_message>
Resolve semester baseline comparison conflicts
Co-authored-by: Колесников Владислав <krons2486@users.noreply.github.com>
</commit_message>
<xml_diff>
--- a/vkr/artifacts/М24-534_НосовАИ_презентация_ВКР.pptx
+++ b/vkr/artifacts/М24-534_НосовАИ_презентация_ВКР.pptx
@@ -2383,7 +2383,7 @@
 </file>
 
 <file path=ppt/notesSlides/notesSlide13.xml><?xml version="1.0" encoding="utf-8"?>
-<p:notes xmlns:a="http://schemas.openxmlformats.org/drawingml/2006/main" xmlns:r="http://schemas.openxmlformats.org/officeDocument/2006/relationships" xmlns:p="http://schemas.openxmlformats.org/presentationml/2006/main" showMasterSp="0" showMasterPhAnim="0">
+<p:notes xmlns:a="http://schemas.openxmlformats.org/drawingml/2006/main" xmlns:p="http://schemas.openxmlformats.org/presentationml/2006/main" showMasterSp="0" showMasterPhAnim="0">
   <p:cSld>
     <p:spTree>
       <p:nvGrpSpPr>
@@ -2447,7 +2447,7 @@
             </a:pPr>
             <a:r>
               <a:rPr lang="ru-RU"/>
-              <a:t>Оценка проводилась по двум задачам. Первая — бинарная классификация: нужно отличить релевантное резюме от нерелевантного. Baseline — это та же модель до fine-tuning: Average Precision всего 26 процентов, то есть модель практически случайная. После обучения точность = 98 процентов, F1 = 96 процентов. Вторая задача — ранжирование: для каждой вакансии дан набор кандидатов, нужно поставить релевантного на первое место. Результат — NDCG@1 равен 1.0 (</a:t>
+              <a:t>Оценка проводилась по двум задачам. Первая — бинарная классификация: нужно отличить релевантное резюме от нерелевантного. Контрольный ориентир — та же модель до fine-tuning, поэтому сравнение показывает вклад доменного дообучения при одинаковой архитектуре. На validation Average Precision выросла с 26 до 98,7 процента, F1 — с 50,8 до 96 процентов, accuracy — с 66 до 97,3 процента. Вторая задача — ранжирование: для каждой вакансии дан набор кандидатов, нужно поставить релевантного выше. На 33 вакансиях, где NDCG математически определена, NDCG@3 равна 1.0; на 119 вакансиях с хотя бы одним positive Precision@3 равна 0.9958. Это офлайн-оценка на подготовленных split-файлах, а не онлайн A/B-тест.</a:t>
             </a:r>
             <a:r>
               <a:rPr lang="ru-RU" sz="1100" i="1">
@@ -2456,7 +2456,7 @@
                 <a:cs typeface="Arial"/>
                 <a:sym typeface="Arial"/>
               </a:rPr>
-              <a:t>Normalized Discounted Cumulative Gain at 1</a:t>
+              <a:t/>
             </a:r>
             <a:r>
               <a:rPr lang="ru-RU" sz="1100">
@@ -2465,7 +2465,7 @@
                 <a:cs typeface="Arial"/>
                 <a:sym typeface="Arial"/>
               </a:rPr>
-              <a:t>, по-русски: </a:t>
+              <a:t/>
             </a:r>
             <a:r>
               <a:rPr lang="ru-RU" sz="1100" b="1">
@@ -2474,7 +2474,7 @@
                 <a:cs typeface="Arial"/>
                 <a:sym typeface="Arial"/>
               </a:rPr>
-              <a:t>нормализованная дисконтированная кумулятивная выгода на первой позиции</a:t>
+              <a:t/>
             </a:r>
             <a:r>
               <a:rPr lang="ru-RU" sz="1100">
@@ -2483,11 +2483,11 @@
                 <a:cs typeface="Arial"/>
                 <a:sym typeface="Arial"/>
               </a:rPr>
-              <a:t>. </a:t>
+              <a:t/>
             </a:r>
             <a:r>
               <a:rPr lang="ru-RU"/>
-              <a:t>), MRR равен 1.0 (</a:t>
+              <a:t/>
             </a:r>
             <a:r>
               <a:rPr lang="ru-RU" sz="1100" i="1">
@@ -2496,7 +2496,7 @@
                 <a:cs typeface="Arial"/>
                 <a:sym typeface="Arial"/>
               </a:rPr>
-              <a:t>Mean Reciprocal Rank</a:t>
+              <a:t/>
             </a:r>
             <a:r>
               <a:rPr lang="ru-RU" sz="1100">
@@ -2505,7 +2505,7 @@
                 <a:cs typeface="Arial"/>
                 <a:sym typeface="Arial"/>
               </a:rPr>
-              <a:t>, по-русски: </a:t>
+              <a:t/>
             </a:r>
             <a:r>
               <a:rPr lang="ru-RU" sz="1100" b="1">
@@ -2514,7 +2514,7 @@
                 <a:cs typeface="Arial"/>
                 <a:sym typeface="Arial"/>
               </a:rPr>
-              <a:t>средний обратный ранг</a:t>
+              <a:t/>
             </a:r>
             <a:r>
               <a:rPr lang="ru-RU" sz="1100">
@@ -2523,11 +2523,11 @@
                 <a:cs typeface="Arial"/>
                 <a:sym typeface="Arial"/>
               </a:rPr>
-              <a:t>. </a:t>
+              <a:t/>
             </a:r>
             <a:r>
               <a:rPr lang="ru-RU"/>
-              <a:t>). Это означает, что во всех тестовых случаях модель поставила правильного кандидата на первое место.</a:t>
+              <a:t/>
             </a:r>
             <a:endParaRPr/>
           </a:p>
@@ -2609,7 +2609,7 @@
 </file>
 
 <file path=ppt/notesSlides/notesSlide14.xml><?xml version="1.0" encoding="utf-8"?>
-<p:notes xmlns:a="http://schemas.openxmlformats.org/drawingml/2006/main" xmlns:r="http://schemas.openxmlformats.org/officeDocument/2006/relationships" xmlns:p="http://schemas.openxmlformats.org/presentationml/2006/main" showMasterSp="0" showMasterPhAnim="0">
+<p:notes xmlns:a="http://schemas.openxmlformats.org/drawingml/2006/main" xmlns:p="http://schemas.openxmlformats.org/presentationml/2006/main" showMasterSp="0" showMasterPhAnim="0">
   <p:cSld>
     <p:spTree>
       <p:nvGrpSpPr>
@@ -2673,7 +2673,7 @@
             </a:pPr>
             <a:r>
               <a:rPr lang="ru-RU"/>
-              <a:t>В работе реализован и интегрирован в систему подбора персонала модуль семантического ранжирования кандидатов. После дообучения качество модели существенно выросло, что позволяет ускорить первичный скрининг и сократить затраты на LLM-скоринг.</a:t>
+              <a:t>В работе реализован и интегрирован в систему подбора персонала модуль семантического ранжирования кандидатов. После дообучения качество модели улучшилось относительно базовой модели без fine-tuning, что позволяет рассматривать ее как инструмент предварительного ранжирования. Выводы об ускорении первичного скрининга и снижении затрат на LLM-скоринг являются расчетным сценарием и требуют проверки в рабочем контуре.</a:t>
             </a:r>
             <a:endParaRPr/>
           </a:p>
@@ -28653,7 +28653,7 @@
 </file>
 
 <file path=ppt/slides/slide13.xml><?xml version="1.0" encoding="utf-8"?>
-<p:sld xmlns:a="http://schemas.openxmlformats.org/drawingml/2006/main" xmlns:r="http://schemas.openxmlformats.org/officeDocument/2006/relationships" xmlns:p="http://schemas.openxmlformats.org/presentationml/2006/main">
+<p:sld xmlns:a="http://schemas.openxmlformats.org/drawingml/2006/main" xmlns:ns2="http://schemas.microsoft.com/office/drawing/2014/main" xmlns:p="http://schemas.openxmlformats.org/presentationml/2006/main">
   <p:cSld>
     <p:spTree>
       <p:nvGrpSpPr>
@@ -28798,28 +28798,28 @@
                 <a:gridCol w="1203075">
                   <a:extLst>
                     <a:ext uri="{9D8B030D-6E8A-4147-A177-3AD203B41FA5}">
-                      <a16:colId xmlns:a16="http://schemas.microsoft.com/office/drawing/2014/main" val="20000"/>
+                      <ns2:colId val="20000"/>
                     </a:ext>
                   </a:extLst>
                 </a:gridCol>
                 <a:gridCol w="941500">
                   <a:extLst>
                     <a:ext uri="{9D8B030D-6E8A-4147-A177-3AD203B41FA5}">
-                      <a16:colId xmlns:a16="http://schemas.microsoft.com/office/drawing/2014/main" val="20001"/>
+                      <ns2:colId val="20001"/>
                     </a:ext>
                   </a:extLst>
                 </a:gridCol>
                 <a:gridCol w="975900">
                   <a:extLst>
                     <a:ext uri="{9D8B030D-6E8A-4147-A177-3AD203B41FA5}">
-                      <a16:colId xmlns:a16="http://schemas.microsoft.com/office/drawing/2014/main" val="20002"/>
+                      <ns2:colId val="20002"/>
                     </a:ext>
                   </a:extLst>
                 </a:gridCol>
                 <a:gridCol w="771075">
                   <a:extLst>
                     <a:ext uri="{9D8B030D-6E8A-4147-A177-3AD203B41FA5}">
-                      <a16:colId xmlns:a16="http://schemas.microsoft.com/office/drawing/2014/main" val="20003"/>
+                      <ns2:colId val="20003"/>
                     </a:ext>
                   </a:extLst>
                 </a:gridCol>
@@ -28907,7 +28907,7 @@
                       </a:pPr>
                       <a:r>
                         <a:rPr lang="ru-RU" sz="1100" b="1"/>
-                        <a:t>Baseline</a:t>
+                        <a:t>Базовая модель</a:t>
                       </a:r>
                       <a:endParaRPr sz="1100" b="1"/>
                     </a:p>
@@ -29033,7 +29033,7 @@
                       </a:pPr>
                       <a:r>
                         <a:rPr lang="ru-RU" sz="1100" b="1"/>
-                        <a:t>Прирост</a:t>
+                        <a:t>Комментарий</a:t>
                       </a:r>
                       <a:endParaRPr sz="1100" b="1"/>
                     </a:p>
@@ -29079,7 +29079,7 @@
                 </a:tc>
                 <a:extLst>
                   <a:ext uri="{0D108BD9-81ED-4DB2-BD59-A6C34878D82A}">
-                    <a16:rowId xmlns:a16="http://schemas.microsoft.com/office/drawing/2014/main" val="10000"/>
+                    <ns2:rowId val="10000"/>
                   </a:ext>
                 </a:extLst>
               </a:tr>
@@ -29292,7 +29292,7 @@
                       </a:pPr>
                       <a:r>
                         <a:rPr lang="ru-RU"/>
-                        <a:t>+281%</a:t>
+                        <a:t>val-выборка</a:t>
                       </a:r>
                       <a:endParaRPr/>
                     </a:p>
@@ -29338,7 +29338,7 @@
                 </a:tc>
                 <a:extLst>
                   <a:ext uri="{0D108BD9-81ED-4DB2-BD59-A6C34878D82A}">
-                    <a16:rowId xmlns:a16="http://schemas.microsoft.com/office/drawing/2014/main" val="10001"/>
+                    <ns2:rowId val="10001"/>
                   </a:ext>
                 </a:extLst>
               </a:tr>
@@ -29425,7 +29425,7 @@
                       </a:pPr>
                       <a:r>
                         <a:rPr lang="ru-RU"/>
-                        <a:t>—</a:t>
+                        <a:t>0.508</a:t>
                       </a:r>
                       <a:endParaRPr/>
                     </a:p>
@@ -29551,7 +29551,7 @@
                       </a:pPr>
                       <a:r>
                         <a:rPr lang="ru-RU"/>
-                        <a:t>—</a:t>
+                        <a:t>val-выборка</a:t>
                       </a:r>
                       <a:endParaRPr/>
                     </a:p>
@@ -29597,7 +29597,7 @@
                 </a:tc>
                 <a:extLst>
                   <a:ext uri="{0D108BD9-81ED-4DB2-BD59-A6C34878D82A}">
-                    <a16:rowId xmlns:a16="http://schemas.microsoft.com/office/drawing/2014/main" val="10002"/>
+                    <ns2:rowId val="10002"/>
                   </a:ext>
                 </a:extLst>
               </a:tr>
@@ -29684,7 +29684,7 @@
                       </a:pPr>
                       <a:r>
                         <a:rPr lang="ru-RU"/>
-                        <a:t>—</a:t>
+                        <a:t>0.660</a:t>
                       </a:r>
                       <a:endParaRPr/>
                     </a:p>
@@ -29810,7 +29810,7 @@
                       </a:pPr>
                       <a:r>
                         <a:rPr lang="ru-RU"/>
-                        <a:t>—</a:t>
+                        <a:t>val-выборка</a:t>
                       </a:r>
                       <a:endParaRPr/>
                     </a:p>
@@ -29856,7 +29856,7 @@
                 </a:tc>
                 <a:extLst>
                   <a:ext uri="{0D108BD9-81ED-4DB2-BD59-A6C34878D82A}">
-                    <a16:rowId xmlns:a16="http://schemas.microsoft.com/office/drawing/2014/main" val="10003"/>
+                    <ns2:rowId val="10003"/>
                   </a:ext>
                 </a:extLst>
               </a:tr>
@@ -29938,14 +29938,14 @@
                 <a:gridCol w="2373250">
                   <a:extLst>
                     <a:ext uri="{9D8B030D-6E8A-4147-A177-3AD203B41FA5}">
-                      <a16:colId xmlns:a16="http://schemas.microsoft.com/office/drawing/2014/main" val="20000"/>
+                      <ns2:colId val="20000"/>
                     </a:ext>
                   </a:extLst>
                 </a:gridCol>
                 <a:gridCol w="889975">
                   <a:extLst>
                     <a:ext uri="{9D8B030D-6E8A-4147-A177-3AD203B41FA5}">
-                      <a16:colId xmlns:a16="http://schemas.microsoft.com/office/drawing/2014/main" val="20001"/>
+                      <ns2:colId val="20001"/>
                     </a:ext>
                   </a:extLst>
                 </a:gridCol>
@@ -30079,7 +30079,7 @@
                 </a:tc>
                 <a:extLst>
                   <a:ext uri="{0D108BD9-81ED-4DB2-BD59-A6C34878D82A}">
-                    <a16:rowId xmlns:a16="http://schemas.microsoft.com/office/drawing/2014/main" val="10000"/>
+                    <ns2:rowId val="10000"/>
                   </a:ext>
                 </a:extLst>
               </a:tr>
@@ -30103,7 +30103,7 @@
                       </a:pPr>
                       <a:r>
                         <a:rPr lang="ru-RU"/>
-                        <a:t>DCNG@1 / @3 / @5 / @10</a:t>
+                        <a:t>NDCG@1 / @3 / @5 / @10</a:t>
                       </a:r>
                       <a:endParaRPr/>
                     </a:p>
@@ -30212,7 +30212,7 @@
                 </a:tc>
                 <a:extLst>
                   <a:ext uri="{0D108BD9-81ED-4DB2-BD59-A6C34878D82A}">
-                    <a16:rowId xmlns:a16="http://schemas.microsoft.com/office/drawing/2014/main" val="10001"/>
+                    <ns2:rowId val="10001"/>
                   </a:ext>
                 </a:extLst>
               </a:tr>
@@ -30345,7 +30345,7 @@
                 </a:tc>
                 <a:extLst>
                   <a:ext uri="{0D108BD9-81ED-4DB2-BD59-A6C34878D82A}">
-                    <a16:rowId xmlns:a16="http://schemas.microsoft.com/office/drawing/2014/main" val="10002"/>
+                    <ns2:rowId val="10002"/>
                   </a:ext>
                 </a:extLst>
               </a:tr>
@@ -30478,7 +30478,7 @@
                 </a:tc>
                 <a:extLst>
                   <a:ext uri="{0D108BD9-81ED-4DB2-BD59-A6C34878D82A}">
-                    <a16:rowId xmlns:a16="http://schemas.microsoft.com/office/drawing/2014/main" val="10003"/>
+                    <ns2:rowId val="10003"/>
                   </a:ext>
                 </a:extLst>
               </a:tr>
@@ -30548,7 +30548,7 @@
 </file>
 
 <file path=ppt/slides/slide14.xml><?xml version="1.0" encoding="utf-8"?>
-<p:sld xmlns:a="http://schemas.openxmlformats.org/drawingml/2006/main" xmlns:r="http://schemas.openxmlformats.org/officeDocument/2006/relationships" xmlns:p="http://schemas.openxmlformats.org/presentationml/2006/main">
+<p:sld xmlns:a="http://schemas.openxmlformats.org/drawingml/2006/main" xmlns:p="http://schemas.openxmlformats.org/presentationml/2006/main">
   <p:cSld>
     <p:spTree>
       <p:nvGrpSpPr>
@@ -30665,7 +30665,7 @@
             </a:pPr>
             <a:r>
               <a:rPr lang="ru-RU" sz="2300"/>
-              <a:t>В результате работы разработан и внедрён модуль семантического ранжирования кандидатов на основе bi-encoder модели rubert-tiny2, интегрированный в ATS Reqcore как FastAPI-микросервис. Модель показала существенный прирост качества: Average Precision на validation выросла с 0.259 до 0.987, а на тестовом срезе достигнуты NDCG@3 = 1.0, MRR = 1.0 и Precision@3 = 0.996. Практически это позволяет сократить стоимость LLM-скоринга примерно на 90% и ускорить этап первичного скрининга кандидатов.</a:t>
+              <a:t>В результате работы разработан и интегрирован в ATS Reqcore модуль семантического ранжирования кандидатов на основе bi-encoder модели rubert-tiny2. В офлайн-оценке модель после fine-tuning показала улучшение относительно контрольной базовой модели без дообучения: Average Precision на validation выросла с 0.259 до 0.987; на тестовом срезе получены NDCG@3 = 1.0, MRR = 1.0 и Precision@3 = 0.996 для подмножеств, где эти метрики определены. Экономический эффект и ускорение скрининга рассматриваются как расчетный сценарий при использовании модели для предварительного top-K отбора, а не как результат production A/B-теста.</a:t>
             </a:r>
             <a:endParaRPr sz="2300"/>
           </a:p>

</xml_diff>

<commit_message>
Neutralize source platform naming and standardize bi-encoder terminology in VKR.
Apply terminology and metrics-table fixes on the objective-baseline branch: neutral data-source wording, Russian ML terms with English in parentheses, and a three-column val comparison table without redundant gain columns.

Co-authored-by: Cursor <cursoragent@cursor.com>
</commit_message>
<xml_diff>
--- a/vkr/artifacts/М24-534_НосовАИ_презентация_ВКР.pptx
+++ b/vkr/artifacts/М24-534_НосовАИ_презентация_ВКР.pptx
@@ -4883,7 +4883,7 @@
             </a:pPr>
             <a:r>
               <a:rPr lang="ru-RU"/>
-              <a:t>В работе был разработан модуль семантического ранжирования и встроен в архитектуру системы подбора персонала. На слайде показано, что реализованы offline-пайплайн подготовки и обучения модели, FastAPI-сервис для расчёта оценки соответствия и ранжирования кандидатов, а также интеграция с backend системы через отдельный bi-encoder путь </a:t>
+              <a:t>В работе был разработан модуль семантического ранжирования и встроен в архитектуру системы подбора персонала. На слайде показано, что реализованы offline-пайплайн подготовки и обучения модели, FastAPI-сервис для расчёта оценки соответствия и ранжирования кандидатов, а также интеграция с backend системы через отдельный независимый энкодер (bi-encoder) путь </a:t>
             </a:r>
             <a:endParaRPr/>
           </a:p>
@@ -27194,7 +27194,7 @@
                       </a:pPr>
                       <a:r>
                         <a:rPr lang="ru-RU" sz="1100" b="1"/>
-                        <a:t>Bi-Encoder (Sentence-BERT)</a:t>
+                        <a:t>независимый энкодер (независимый энкодер (bi-encoder), Sentence-BERT)</a:t>
                       </a:r>
                       <a:endParaRPr sz="1100" b="1"/>
                     </a:p>
@@ -28970,7 +28970,7 @@
                       </a:pPr>
                       <a:r>
                         <a:rPr lang="ru-RU" sz="1100" b="1"/>
-                        <a:t>Fine-Tuned</a:t>
+                        <a:t>Дообученная модель</a:t>
                       </a:r>
                       <a:endParaRPr sz="1100" b="1"/>
                     </a:p>
@@ -29033,7 +29033,6 @@
                       </a:pPr>
                       <a:r>
                         <a:rPr lang="ru-RU" sz="1100" b="1"/>
-                        <a:t>Комментарий</a:t>
                       </a:r>
                       <a:endParaRPr sz="1100" b="1"/>
                     </a:p>
@@ -29292,7 +29291,6 @@
                       </a:pPr>
                       <a:r>
                         <a:rPr lang="ru-RU"/>
-                        <a:t>val-выборка</a:t>
                       </a:r>
                       <a:endParaRPr/>
                     </a:p>
@@ -29551,7 +29549,6 @@
                       </a:pPr>
                       <a:r>
                         <a:rPr lang="ru-RU"/>
-                        <a:t>val-выборка</a:t>
                       </a:r>
                       <a:endParaRPr/>
                     </a:p>
@@ -29810,7 +29807,6 @@
                       </a:pPr>
                       <a:r>
                         <a:rPr lang="ru-RU"/>
-                        <a:t>val-выборка</a:t>
                       </a:r>
                       <a:endParaRPr/>
                     </a:p>
@@ -30665,7 +30661,7 @@
             </a:pPr>
             <a:r>
               <a:rPr lang="ru-RU" sz="2300"/>
-              <a:t>В результате работы разработан и интегрирован в ATS Reqcore модуль семантического ранжирования кандидатов на основе bi-encoder модели rubert-tiny2. В офлайн-оценке модель после fine-tuning показала улучшение относительно контрольной базовой модели без дообучения: Average Precision на validation выросла с 0.259 до 0.987; на тестовом срезе получены NDCG@3 = 1.0, MRR = 1.0 и Precision@3 = 0.996 для подмножеств, где эти метрики определены. Экономический эффект и ускорение скрининга рассматриваются как расчетный сценарий при использовании модели для предварительного top-K отбора, а не как результат production A/B-теста.</a:t>
+              <a:t>В результате работы разработан и интегрирован в ATS Reqcore модуль семантического ранжирования кандидатов на основе независимый энкодер (bi-encoder) модели rubert-tiny2. В офлайн-оценке модель после fine-tuning показала улучшение относительно контрольной базовой модели без дообучения: Average Precision на validation выросла с 0.259 до 0.987; на тестовом срезе получены NDCG@3 = 1.0, MRR = 1.0 и Precision@3 = 0.996 для подмножеств, где эти метрики определены. Экономический эффект и ускорение скрининга рассматриваются как расчетный сценарий при использовании модели для предварительного top-K отбора, а не как результат production A/B-теста.</a:t>
             </a:r>
             <a:endParaRPr sz="2300"/>
           </a:p>
@@ -31709,7 +31705,7 @@
             </a:pPr>
             <a:r>
               <a:rPr lang="ru-RU" sz="2000"/>
-              <a:t>Ключевые слова: ATS, рекрутмент, ранжирование кандидатов, семантическое сопоставление, обработка естественного языка, bi-encoder, Sentence-BERT, FastAPI, интеграция с ATS, Reqcore.</a:t>
+              <a:t>Ключевые слова: ATS, рекрутмент, ранжирование кандидатов, семантическое сопоставление, обработка естественного языка, независимый энкодер (bi-encoder), Sentence-BERT, FastAPI, интеграция с ATS, Reqcore.</a:t>
             </a:r>
             <a:endParaRPr sz="2000"/>
           </a:p>

</xml_diff>

<commit_message>
Neutralize SuperJob naming and standardize bi-encoder terminology in VKR.
Apply terminology and metrics-table fixes on the objective-baseline branch: neutral data-source wording, Russian ML terms with English in parentheses, and a three-column val comparison table without redundant gain columns.

Co-authored-by: Cursor <cursoragent@cursor.com>
</commit_message>
<xml_diff>
--- a/vkr/artifacts/М24-534_НосовАИ_презентация_ВКР.pptx
+++ b/vkr/artifacts/М24-534_НосовАИ_презентация_ВКР.pptx
@@ -4883,7 +4883,7 @@
             </a:pPr>
             <a:r>
               <a:rPr lang="ru-RU"/>
-              <a:t>В работе был разработан модуль семантического ранжирования и встроен в архитектуру системы подбора персонала. На слайде показано, что реализованы offline-пайплайн подготовки и обучения модели, FastAPI-сервис для расчёта оценки соответствия и ранжирования кандидатов, а также интеграция с backend системы через отдельный bi-encoder путь </a:t>
+              <a:t>В работе был разработан модуль семантического ранжирования и встроен в архитектуру системы подбора персонала. На слайде показано, что реализованы offline-пайплайн подготовки и обучения модели, FastAPI-сервис для расчёта оценки соответствия и ранжирования кандидатов, а также интеграция с backend системы через отдельный независимый энкодер (bi-encoder) путь </a:t>
             </a:r>
             <a:endParaRPr/>
           </a:p>
@@ -27194,7 +27194,7 @@
                       </a:pPr>
                       <a:r>
                         <a:rPr lang="ru-RU" sz="1100" b="1"/>
-                        <a:t>Bi-Encoder (Sentence-BERT)</a:t>
+                        <a:t>независимый энкодер (независимый энкодер (bi-encoder), Sentence-BERT)</a:t>
                       </a:r>
                       <a:endParaRPr sz="1100" b="1"/>
                     </a:p>
@@ -28970,7 +28970,7 @@
                       </a:pPr>
                       <a:r>
                         <a:rPr lang="ru-RU" sz="1100" b="1"/>
-                        <a:t>Fine-Tuned</a:t>
+                        <a:t>Дообученная модель</a:t>
                       </a:r>
                       <a:endParaRPr sz="1100" b="1"/>
                     </a:p>
@@ -29033,7 +29033,6 @@
                       </a:pPr>
                       <a:r>
                         <a:rPr lang="ru-RU" sz="1100" b="1"/>
-                        <a:t>Комментарий</a:t>
                       </a:r>
                       <a:endParaRPr sz="1100" b="1"/>
                     </a:p>
@@ -29292,7 +29291,6 @@
                       </a:pPr>
                       <a:r>
                         <a:rPr lang="ru-RU"/>
-                        <a:t>val-выборка</a:t>
                       </a:r>
                       <a:endParaRPr/>
                     </a:p>
@@ -29551,7 +29549,6 @@
                       </a:pPr>
                       <a:r>
                         <a:rPr lang="ru-RU"/>
-                        <a:t>val-выборка</a:t>
                       </a:r>
                       <a:endParaRPr/>
                     </a:p>
@@ -29810,7 +29807,6 @@
                       </a:pPr>
                       <a:r>
                         <a:rPr lang="ru-RU"/>
-                        <a:t>val-выборка</a:t>
                       </a:r>
                       <a:endParaRPr/>
                     </a:p>
@@ -30665,7 +30661,7 @@
             </a:pPr>
             <a:r>
               <a:rPr lang="ru-RU" sz="2300"/>
-              <a:t>В результате работы разработан и интегрирован в ATS Reqcore модуль семантического ранжирования кандидатов на основе bi-encoder модели rubert-tiny2. В офлайн-оценке модель после fine-tuning показала улучшение относительно контрольной базовой модели без дообучения: Average Precision на validation выросла с 0.259 до 0.987; на тестовом срезе получены NDCG@3 = 1.0, MRR = 1.0 и Precision@3 = 0.996 для подмножеств, где эти метрики определены. Экономический эффект и ускорение скрининга рассматриваются как расчетный сценарий при использовании модели для предварительного top-K отбора, а не как результат production A/B-теста.</a:t>
+              <a:t>В результате работы разработан и интегрирован в ATS Reqcore модуль семантического ранжирования кандидатов на основе независимый энкодер (bi-encoder) модели rubert-tiny2. В офлайн-оценке модель после fine-tuning показала улучшение относительно контрольной базовой модели без дообучения: Average Precision на validation выросла с 0.259 до 0.987; на тестовом срезе получены NDCG@3 = 1.0, MRR = 1.0 и Precision@3 = 0.996 для подмножеств, где эти метрики определены. Экономический эффект и ускорение скрининга рассматриваются как расчетный сценарий при использовании модели для предварительного top-K отбора, а не как результат production A/B-теста.</a:t>
             </a:r>
             <a:endParaRPr sz="2300"/>
           </a:p>
@@ -31709,7 +31705,7 @@
             </a:pPr>
             <a:r>
               <a:rPr lang="ru-RU" sz="2000"/>
-              <a:t>Ключевые слова: ATS, рекрутмент, ранжирование кандидатов, семантическое сопоставление, обработка естественного языка, bi-encoder, Sentence-BERT, FastAPI, интеграция с ATS, Reqcore.</a:t>
+              <a:t>Ключевые слова: ATS, рекрутмент, ранжирование кандидатов, семантическое сопоставление, обработка естественного языка, независимый энкодер (bi-encoder), Sentence-BERT, FastAPI, интеграция с ATS, Reqcore.</a:t>
             </a:r>
             <a:endParaRPr sz="2000"/>
           </a:p>

</xml_diff>